<commit_message>
Draw the query bars as shapes instead of a native chart
Without LibreOffice here I could not render the deck, and native chart XML
from pptxgenjs is the one part PowerPoint sometimes refuses while every other
tool accepts. Shapes cannot fail that way.

Co-Authored-By: Claude Opus 5 <noreply@anthropic.com>
</commit_message>
<xml_diff>
--- a/SEM-PRESENTACION-PRIYA.pptx
+++ b/SEM-PRESENTACION-PRIYA.pptx
@@ -116,416 +116,6 @@
     </a:lvl9pPr>
   </p:defaultTextStyle>
 </p:presentation>
-</file>
-
-<file path=ppt/charts/chart1.xml><?xml version="1.0" encoding="utf-8"?>
-<c:chartSpace xmlns:c="http://schemas.openxmlformats.org/drawingml/2006/chart" xmlns:a="http://schemas.openxmlformats.org/drawingml/2006/main" xmlns:r="http://schemas.openxmlformats.org/officeDocument/2006/relationships">
-  <c:date1904 val="0"/>
-  <c:roundedCorners val="1"/>
-  <c:chart>
-    <c:title>
-      <c:tx>
-        <c:rich>
-          <a:bodyPr/>
-          <a:lstStyle/>
-          <a:p>
-            <a:pPr>
-              <a:defRPr sz="1100" b="0" i="0" u="none" strike="noStrike">
-                <a:solidFill>
-                  <a:srgbClr val="3C3D3F"/>
-                </a:solidFill>
-                <a:latin typeface="Calibri"/>
-              </a:defRPr>
-            </a:pPr>
-            <a:r>
-              <a:rPr sz="1100" b="0" i="0" u="none" strike="noStrike">
-                <a:solidFill>
-                  <a:srgbClr val="3C3D3F"/>
-                </a:solidFill>
-                <a:latin typeface="Calibri"/>
-              </a:rPr>
-              <a:t>Top 10 searches by clicks</a:t>
-            </a:r>
-          </a:p>
-        </c:rich>
-      </c:tx>
-      <c:layout/>
-      <c:overlay val="0"/>
-    </c:title>
-    <c:autoTitleDeleted val="0"/>
-    <c:plotArea>
-      <c:layout/>
-      <c:barChart>
-        <c:barDir val="bar"/>
-        <c:grouping val="clustered"/>
-        <c:varyColors val="0"/>
-        <c:ser>
-          <c:idx val="0"/>
-          <c:order val="0"/>
-          <c:tx>
-            <c:strRef>
-              <c:f>Sheet1!$B$1</c:f>
-              <c:strCache>
-                <c:ptCount val="1"/>
-                <c:pt idx="0">
-                  <c:v>Clicks</c:v>
-                </c:pt>
-              </c:strCache>
-            </c:strRef>
-          </c:tx>
-          <c:spPr>
-            <a:solidFill>
-              <a:srgbClr val="00A6CE"/>
-            </a:solidFill>
-            <a:effectLst/>
-          </c:spPr>
-          <c:invertIfNegative val="0"/>
-          <c:dLbls>
-            <c:numFmt formatCode="#,##0" sourceLinked="0"/>
-            <c:txPr>
-              <a:bodyPr/>
-              <a:lstStyle/>
-              <a:p>
-                <a:pPr>
-                  <a:defRPr b="0" i="0" strike="noStrike" sz="900" u="none">
-                    <a:solidFill>
-                      <a:srgbClr val="3C3D3F"/>
-                    </a:solidFill>
-                    <a:latin typeface="Calibri"/>
-                  </a:defRPr>
-                </a:pPr>
-              </a:p>
-            </c:txPr>
-            <c:showLegendKey val="0"/>
-            <c:showVal val="1"/>
-            <c:showCatName val="0"/>
-            <c:showSerName val="0"/>
-            <c:showPercent val="0"/>
-            <c:showBubbleSize val="0"/>
-            <c:showLeaderLines val="0"/>
-          </c:dLbls>
-          <c:dPt>
-            <c:idx val="0"/>
-            <c:invertIfNegative val="0"/>
-            <c:bubble3D val="0"/>
-            <c:spPr>
-              <a:solidFill>
-                <a:srgbClr val="00A6CE"/>
-              </a:solidFill>
-              <a:effectLst/>
-            </c:spPr>
-          </c:dPt>
-          <c:dPt>
-            <c:idx val="1"/>
-            <c:invertIfNegative val="0"/>
-            <c:bubble3D val="0"/>
-            <c:spPr>
-              <a:solidFill>
-                <a:srgbClr val="00A6CE"/>
-              </a:solidFill>
-              <a:effectLst/>
-            </c:spPr>
-          </c:dPt>
-          <c:dPt>
-            <c:idx val="2"/>
-            <c:invertIfNegative val="0"/>
-            <c:bubble3D val="0"/>
-            <c:spPr>
-              <a:solidFill>
-                <a:srgbClr val="00A6CE"/>
-              </a:solidFill>
-              <a:effectLst/>
-            </c:spPr>
-          </c:dPt>
-          <c:dPt>
-            <c:idx val="3"/>
-            <c:invertIfNegative val="0"/>
-            <c:bubble3D val="0"/>
-            <c:spPr>
-              <a:solidFill>
-                <a:srgbClr val="00A6CE"/>
-              </a:solidFill>
-              <a:effectLst/>
-            </c:spPr>
-          </c:dPt>
-          <c:dPt>
-            <c:idx val="4"/>
-            <c:invertIfNegative val="0"/>
-            <c:bubble3D val="0"/>
-            <c:spPr>
-              <a:solidFill>
-                <a:srgbClr val="00A6CE"/>
-              </a:solidFill>
-              <a:effectLst/>
-            </c:spPr>
-          </c:dPt>
-          <c:dPt>
-            <c:idx val="5"/>
-            <c:invertIfNegative val="0"/>
-            <c:bubble3D val="0"/>
-            <c:spPr>
-              <a:solidFill>
-                <a:srgbClr val="00A6CE"/>
-              </a:solidFill>
-              <a:effectLst/>
-            </c:spPr>
-          </c:dPt>
-          <c:dPt>
-            <c:idx val="6"/>
-            <c:invertIfNegative val="0"/>
-            <c:bubble3D val="0"/>
-            <c:spPr>
-              <a:solidFill>
-                <a:srgbClr val="00A6CE"/>
-              </a:solidFill>
-              <a:effectLst/>
-            </c:spPr>
-          </c:dPt>
-          <c:dPt>
-            <c:idx val="7"/>
-            <c:invertIfNegative val="0"/>
-            <c:bubble3D val="0"/>
-            <c:spPr>
-              <a:solidFill>
-                <a:srgbClr val="00A6CE"/>
-              </a:solidFill>
-              <a:effectLst/>
-            </c:spPr>
-          </c:dPt>
-          <c:dPt>
-            <c:idx val="8"/>
-            <c:invertIfNegative val="0"/>
-            <c:bubble3D val="0"/>
-            <c:spPr>
-              <a:solidFill>
-                <a:srgbClr val="00A6CE"/>
-              </a:solidFill>
-              <a:effectLst/>
-            </c:spPr>
-          </c:dPt>
-          <c:dPt>
-            <c:idx val="9"/>
-            <c:invertIfNegative val="0"/>
-            <c:bubble3D val="0"/>
-            <c:spPr>
-              <a:solidFill>
-                <a:srgbClr val="0A7390"/>
-              </a:solidFill>
-              <a:effectLst/>
-            </c:spPr>
-          </c:dPt>
-          <c:cat>
-            <c:multiLvlStrRef>
-              <c:f>Sheet1!$A$2:$A$11</c:f>
-              <c:multiLvlStrCache>
-                <c:ptCount val="10"/>
-                <c:lvl>
-                  <c:pt idx="0">
-                    <c:v>du liban</c:v>
-                  </c:pt>
-                  <c:pt idx="1">
-                    <c:v>duliban</c:v>
-                  </c:pt>
-                  <c:pt idx="2">
-                    <c:v>du liban moraleja</c:v>
-                  </c:pt>
-                  <c:pt idx="3">
-                    <c:v>du liban madrid</c:v>
-                  </c:pt>
-                  <c:pt idx="4">
-                    <c:v>duliban restaurante</c:v>
-                  </c:pt>
-                  <c:pt idx="5">
-                    <c:v>du liban restaurante</c:v>
-                  </c:pt>
-                  <c:pt idx="6">
-                    <c:v>duliban la moraleja</c:v>
-                  </c:pt>
-                  <c:pt idx="7">
-                    <c:v>restaurante du liban</c:v>
-                  </c:pt>
-                  <c:pt idx="8">
-                    <c:v>du liban la moraleja</c:v>
-                  </c:pt>
-                  <c:pt idx="9">
-                    <c:v>libanes la moraleja</c:v>
-                  </c:pt>
-                </c:lvl>
-              </c:multiLvlStrCache>
-            </c:multiLvlStrRef>
-          </c:cat>
-          <c:val>
-            <c:numRef>
-              <c:f>Sheet1!$B$2:$B$11</c:f>
-              <c:numCache>
-                <c:formatCode>General</c:formatCode>
-                <c:ptCount val="10"/>
-                <c:pt idx="0">
-                  <c:v>73</c:v>
-                </c:pt>
-                <c:pt idx="1">
-                  <c:v>41</c:v>
-                </c:pt>
-                <c:pt idx="2">
-                  <c:v>14</c:v>
-                </c:pt>
-                <c:pt idx="3">
-                  <c:v>11</c:v>
-                </c:pt>
-                <c:pt idx="4">
-                  <c:v>9</c:v>
-                </c:pt>
-                <c:pt idx="5">
-                  <c:v>9</c:v>
-                </c:pt>
-                <c:pt idx="6">
-                  <c:v>8</c:v>
-                </c:pt>
-                <c:pt idx="7">
-                  <c:v>7</c:v>
-                </c:pt>
-                <c:pt idx="8">
-                  <c:v>5</c:v>
-                </c:pt>
-                <c:pt idx="9">
-                  <c:v>5</c:v>
-                </c:pt>
-              </c:numCache>
-            </c:numRef>
-          </c:val>
-        </c:ser>
-        <c:dLbls>
-          <c:numFmt formatCode="#,##0" sourceLinked="0"/>
-          <c:txPr>
-            <a:bodyPr/>
-            <a:lstStyle/>
-            <a:p>
-              <a:pPr>
-                <a:defRPr b="0" i="0" strike="noStrike" sz="900" u="none">
-                  <a:solidFill>
-                    <a:srgbClr val="3C3D3F"/>
-                  </a:solidFill>
-                  <a:latin typeface="Calibri"/>
-                </a:defRPr>
-              </a:pPr>
-            </a:p>
-          </c:txPr>
-          <c:showLegendKey val="0"/>
-          <c:showVal val="1"/>
-          <c:showCatName val="0"/>
-          <c:showSerName val="0"/>
-          <c:showPercent val="0"/>
-          <c:showBubbleSize val="0"/>
-          <c:showLeaderLines val="0"/>
-        </c:dLbls>
-        <c:gapWidth val="150"/>
-        <c:overlap val="0"/>
-        <c:axId val="2094734554"/>
-        <c:axId val="2094734552"/>
-        <c:axId val="2094734556"/>
-      </c:barChart>
-      <c:catAx>
-        <c:axId val="2094734554"/>
-        <c:scaling>
-          <c:orientation val="maxMin"/>
-        </c:scaling>
-        <c:delete val="0"/>
-        <c:axPos val="l"/>
-        <c:numFmt formatCode="General" sourceLinked="1"/>
-        <c:majorTickMark val="out"/>
-        <c:minorTickMark val="none"/>
-        <c:tickLblPos val="nextTo"/>
-        <c:spPr>
-          <a:ln w="12700" cap="flat">
-            <a:solidFill>
-              <a:srgbClr val="888888"/>
-            </a:solidFill>
-            <a:prstDash val="solid"/>
-            <a:round/>
-          </a:ln>
-        </c:spPr>
-        <c:txPr>
-          <a:bodyPr/>
-          <a:lstStyle/>
-          <a:p>
-            <a:pPr>
-              <a:defRPr sz="900" b="0" i="0" u="none" strike="noStrike">
-                <a:solidFill>
-                  <a:srgbClr val="3C3D3F"/>
-                </a:solidFill>
-                <a:latin typeface="Calibri"/>
-              </a:defRPr>
-            </a:pPr>
-            <a:endParaRPr lang="en-US"/>
-          </a:p>
-        </c:txPr>
-        <c:crossAx val="2094734552"/>
-        <c:crosses val="autoZero"/>
-        <c:auto val="1"/>
-        <c:lblAlgn val="ctr"/>
-        <c:noMultiLvlLbl val="1"/>
-      </c:catAx>
-      <c:valAx>
-        <c:axId val="2094734552"/>
-        <c:scaling>
-          <c:orientation val="minMax"/>
-        </c:scaling>
-        <c:delete val="1"/>
-        <c:axPos val="b"/>
-        <c:numFmt formatCode="General" sourceLinked="0"/>
-        <c:majorTickMark val="out"/>
-        <c:minorTickMark val="none"/>
-        <c:tickLblPos val="low"/>
-        <c:spPr>
-          <a:ln w="12700" cap="flat">
-            <a:solidFill>
-              <a:srgbClr val="888888"/>
-            </a:solidFill>
-            <a:prstDash val="solid"/>
-            <a:round/>
-          </a:ln>
-        </c:spPr>
-        <c:txPr>
-          <a:bodyPr/>
-          <a:lstStyle/>
-          <a:p>
-            <a:pPr>
-              <a:defRPr sz="1200" b="0" i="0" u="none" strike="noStrike">
-                <a:solidFill>
-                  <a:srgbClr val="000000"/>
-                </a:solidFill>
-                <a:latin typeface="Arial"/>
-              </a:defRPr>
-            </a:pPr>
-            <a:endParaRPr lang="en-US"/>
-          </a:p>
-        </c:txPr>
-        <c:crossAx val="2094734554"/>
-        <c:crosses val="autoZero"/>
-        <c:crossBetween val="between"/>
-      </c:valAx>
-      <c:spPr>
-        <a:noFill/>
-        <a:ln>
-          <a:noFill/>
-        </a:ln>
-        <a:effectLst/>
-      </c:spPr>
-    </c:plotArea>
-    <c:plotVisOnly val="1"/>
-    <c:dispBlanksAs val="span"/>
-  </c:chart>
-  <c:spPr>
-    <a:noFill/>
-    <a:ln>
-      <a:noFill/>
-    </a:ln>
-    <a:effectLst/>
-  </c:spPr>
-  <c:externalData r:id="rId1">
-    <c:autoUpdate val="0"/>
-  </c:externalData>
-</c:chartSpace>
 </file>
 
 <file path=ppt/notesMasters/notesMaster1.xml><?xml version="1.0" encoding="utf-8"?>
@@ -2289,7 +1879,7 @@
               <a:buNone/>
             </a:pPr>
             <a:r>
-              <a:rPr lang="en-US" sz="1600" spc="600" kern="0" dirty="0">
+              <a:rPr lang="en-US" sz="1600" dirty="0">
                 <a:solidFill>
                   <a:srgbClr val="C9B98C"/>
                 </a:solidFill>
@@ -4350,25 +3940,1078 @@
           </a:p>
         </p:txBody>
       </p:sp>
-      <p:graphicFrame>
-        <p:nvGraphicFramePr>
-          <p:cNvPr id="10" name="Chart 0" descr=""/>
-          <p:cNvGraphicFramePr/>
-          <p:nvPr/>
-        </p:nvGraphicFramePr>
-        <p:xfrm>
-          <a:off x="457200" y="2743200"/>
-          <a:ext cx="5120640" cy="1920240"/>
-        </p:xfrm>
-        <a:graphic xmlns:a="http://schemas.openxmlformats.org/drawingml/2006/main">
-          <a:graphicData uri="http://schemas.openxmlformats.org/drawingml/2006/chart">
-            <c:chart xmlns:c="http://schemas.openxmlformats.org/drawingml/2006/chart" r:id="rId1"/>
-          </a:graphicData>
-        </a:graphic>
-      </p:graphicFrame>
-      <p:sp>
-        <p:nvSpPr>
-          <p:cNvPr id="11" name="Shape 8"/>
+      <p:sp>
+        <p:nvSpPr>
+          <p:cNvPr id="10" name="Text 8"/>
+          <p:cNvSpPr txBox="1"/>
+          <p:nvPr/>
+        </p:nvSpPr>
+        <p:spPr>
+          <a:xfrm>
+            <a:off x="457200" y="2697480"/>
+            <a:ext cx="5120640" cy="228600"/>
+          </a:xfrm>
+          <a:prstGeom prst="rect">
+            <a:avLst/>
+          </a:prstGeom>
+          <a:noFill/>
+          <a:ln/>
+        </p:spPr>
+        <p:txBody>
+          <a:bodyPr wrap="square" lIns="0" tIns="0" rIns="0" bIns="0" rtlCol="0" anchor="ctr"/>
+          <a:lstStyle/>
+          <a:p>
+            <a:pPr indent="0" marL="0">
+              <a:buNone/>
+            </a:pPr>
+            <a:r>
+              <a:rPr lang="en-US" sz="1100" b="1" dirty="0">
+                <a:solidFill>
+                  <a:srgbClr val="3C3D3F"/>
+                </a:solidFill>
+                <a:latin typeface="Calibri" pitchFamily="34" charset="0"/>
+                <a:ea typeface="Calibri" pitchFamily="34" charset="-122"/>
+                <a:cs typeface="Calibri" pitchFamily="34" charset="-120"/>
+              </a:rPr>
+              <a:t>Top 10 searches by clicks</a:t>
+            </a:r>
+            <a:endParaRPr lang="en-US" sz="1100" dirty="0"/>
+          </a:p>
+        </p:txBody>
+      </p:sp>
+      <p:sp>
+        <p:nvSpPr>
+          <p:cNvPr id="11" name="Text 9"/>
+          <p:cNvSpPr txBox="1"/>
+          <p:nvPr/>
+        </p:nvSpPr>
+        <p:spPr>
+          <a:xfrm>
+            <a:off x="457200" y="2971800"/>
+            <a:ext cx="1645920" cy="169164"/>
+          </a:xfrm>
+          <a:prstGeom prst="rect">
+            <a:avLst/>
+          </a:prstGeom>
+          <a:noFill/>
+          <a:ln/>
+        </p:spPr>
+        <p:txBody>
+          <a:bodyPr wrap="square" lIns="0" tIns="0" rIns="0" bIns="0" rtlCol="0" anchor="ctr"/>
+          <a:lstStyle/>
+          <a:p>
+            <a:pPr algn="r" indent="0" marL="0">
+              <a:buNone/>
+            </a:pPr>
+            <a:r>
+              <a:rPr lang="en-US" sz="850" dirty="0">
+                <a:solidFill>
+                  <a:srgbClr val="3C3D3F"/>
+                </a:solidFill>
+                <a:latin typeface="Calibri" pitchFamily="34" charset="0"/>
+                <a:ea typeface="Calibri" pitchFamily="34" charset="-122"/>
+                <a:cs typeface="Calibri" pitchFamily="34" charset="-120"/>
+              </a:rPr>
+              <a:t>du liban</a:t>
+            </a:r>
+            <a:endParaRPr lang="en-US" sz="850" dirty="0"/>
+          </a:p>
+        </p:txBody>
+      </p:sp>
+      <p:sp>
+        <p:nvSpPr>
+          <p:cNvPr id="12" name="Shape 10"/>
+          <p:cNvSpPr/>
+          <p:nvPr/>
+        </p:nvSpPr>
+        <p:spPr>
+          <a:xfrm>
+            <a:off x="2148840" y="2999232"/>
+            <a:ext cx="3017520" cy="114300"/>
+          </a:xfrm>
+          <a:prstGeom prst="rect">
+            <a:avLst/>
+          </a:prstGeom>
+          <a:solidFill>
+            <a:srgbClr val="00A6CE"/>
+          </a:solidFill>
+          <a:ln w="12700">
+            <a:solidFill>
+              <a:srgbClr val="00A6CE"/>
+            </a:solidFill>
+            <a:prstDash val="solid"/>
+          </a:ln>
+        </p:spPr>
+      </p:sp>
+      <p:sp>
+        <p:nvSpPr>
+          <p:cNvPr id="13" name="Text 11"/>
+          <p:cNvSpPr txBox="1"/>
+          <p:nvPr/>
+        </p:nvSpPr>
+        <p:spPr>
+          <a:xfrm>
+            <a:off x="5221224" y="2971800"/>
+            <a:ext cx="457200" cy="169164"/>
+          </a:xfrm>
+          <a:prstGeom prst="rect">
+            <a:avLst/>
+          </a:prstGeom>
+          <a:noFill/>
+          <a:ln/>
+        </p:spPr>
+        <p:txBody>
+          <a:bodyPr wrap="square" lIns="0" tIns="0" rIns="0" bIns="0" rtlCol="0" anchor="ctr"/>
+          <a:lstStyle/>
+          <a:p>
+            <a:pPr indent="0" marL="0">
+              <a:buNone/>
+            </a:pPr>
+            <a:r>
+              <a:rPr lang="en-US" sz="850" dirty="0">
+                <a:solidFill>
+                  <a:srgbClr val="3C3D3F"/>
+                </a:solidFill>
+                <a:latin typeface="Calibri" pitchFamily="34" charset="0"/>
+                <a:ea typeface="Calibri" pitchFamily="34" charset="-122"/>
+                <a:cs typeface="Calibri" pitchFamily="34" charset="-120"/>
+              </a:rPr>
+              <a:t>73</a:t>
+            </a:r>
+            <a:endParaRPr lang="en-US" sz="850" dirty="0"/>
+          </a:p>
+        </p:txBody>
+      </p:sp>
+      <p:sp>
+        <p:nvSpPr>
+          <p:cNvPr id="14" name="Text 12"/>
+          <p:cNvSpPr txBox="1"/>
+          <p:nvPr/>
+        </p:nvSpPr>
+        <p:spPr>
+          <a:xfrm>
+            <a:off x="457200" y="3140964"/>
+            <a:ext cx="1645920" cy="169164"/>
+          </a:xfrm>
+          <a:prstGeom prst="rect">
+            <a:avLst/>
+          </a:prstGeom>
+          <a:noFill/>
+          <a:ln/>
+        </p:spPr>
+        <p:txBody>
+          <a:bodyPr wrap="square" lIns="0" tIns="0" rIns="0" bIns="0" rtlCol="0" anchor="ctr"/>
+          <a:lstStyle/>
+          <a:p>
+            <a:pPr algn="r" indent="0" marL="0">
+              <a:buNone/>
+            </a:pPr>
+            <a:r>
+              <a:rPr lang="en-US" sz="850" dirty="0">
+                <a:solidFill>
+                  <a:srgbClr val="3C3D3F"/>
+                </a:solidFill>
+                <a:latin typeface="Calibri" pitchFamily="34" charset="0"/>
+                <a:ea typeface="Calibri" pitchFamily="34" charset="-122"/>
+                <a:cs typeface="Calibri" pitchFamily="34" charset="-120"/>
+              </a:rPr>
+              <a:t>duliban</a:t>
+            </a:r>
+            <a:endParaRPr lang="en-US" sz="850" dirty="0"/>
+          </a:p>
+        </p:txBody>
+      </p:sp>
+      <p:sp>
+        <p:nvSpPr>
+          <p:cNvPr id="15" name="Shape 13"/>
+          <p:cNvSpPr/>
+          <p:nvPr/>
+        </p:nvSpPr>
+        <p:spPr>
+          <a:xfrm>
+            <a:off x="2148840" y="3168396"/>
+            <a:ext cx="1694772" cy="114300"/>
+          </a:xfrm>
+          <a:prstGeom prst="rect">
+            <a:avLst/>
+          </a:prstGeom>
+          <a:solidFill>
+            <a:srgbClr val="00A6CE"/>
+          </a:solidFill>
+          <a:ln w="12700">
+            <a:solidFill>
+              <a:srgbClr val="00A6CE"/>
+            </a:solidFill>
+            <a:prstDash val="solid"/>
+          </a:ln>
+        </p:spPr>
+      </p:sp>
+      <p:sp>
+        <p:nvSpPr>
+          <p:cNvPr id="16" name="Text 14"/>
+          <p:cNvSpPr txBox="1"/>
+          <p:nvPr/>
+        </p:nvSpPr>
+        <p:spPr>
+          <a:xfrm>
+            <a:off x="3898476" y="3140964"/>
+            <a:ext cx="457200" cy="169164"/>
+          </a:xfrm>
+          <a:prstGeom prst="rect">
+            <a:avLst/>
+          </a:prstGeom>
+          <a:noFill/>
+          <a:ln/>
+        </p:spPr>
+        <p:txBody>
+          <a:bodyPr wrap="square" lIns="0" tIns="0" rIns="0" bIns="0" rtlCol="0" anchor="ctr"/>
+          <a:lstStyle/>
+          <a:p>
+            <a:pPr indent="0" marL="0">
+              <a:buNone/>
+            </a:pPr>
+            <a:r>
+              <a:rPr lang="en-US" sz="850" dirty="0">
+                <a:solidFill>
+                  <a:srgbClr val="3C3D3F"/>
+                </a:solidFill>
+                <a:latin typeface="Calibri" pitchFamily="34" charset="0"/>
+                <a:ea typeface="Calibri" pitchFamily="34" charset="-122"/>
+                <a:cs typeface="Calibri" pitchFamily="34" charset="-120"/>
+              </a:rPr>
+              <a:t>41</a:t>
+            </a:r>
+            <a:endParaRPr lang="en-US" sz="850" dirty="0"/>
+          </a:p>
+        </p:txBody>
+      </p:sp>
+      <p:sp>
+        <p:nvSpPr>
+          <p:cNvPr id="17" name="Text 15"/>
+          <p:cNvSpPr txBox="1"/>
+          <p:nvPr/>
+        </p:nvSpPr>
+        <p:spPr>
+          <a:xfrm>
+            <a:off x="457200" y="3310128"/>
+            <a:ext cx="1645920" cy="169164"/>
+          </a:xfrm>
+          <a:prstGeom prst="rect">
+            <a:avLst/>
+          </a:prstGeom>
+          <a:noFill/>
+          <a:ln/>
+        </p:spPr>
+        <p:txBody>
+          <a:bodyPr wrap="square" lIns="0" tIns="0" rIns="0" bIns="0" rtlCol="0" anchor="ctr"/>
+          <a:lstStyle/>
+          <a:p>
+            <a:pPr algn="r" indent="0" marL="0">
+              <a:buNone/>
+            </a:pPr>
+            <a:r>
+              <a:rPr lang="en-US" sz="850" dirty="0">
+                <a:solidFill>
+                  <a:srgbClr val="3C3D3F"/>
+                </a:solidFill>
+                <a:latin typeface="Calibri" pitchFamily="34" charset="0"/>
+                <a:ea typeface="Calibri" pitchFamily="34" charset="-122"/>
+                <a:cs typeface="Calibri" pitchFamily="34" charset="-120"/>
+              </a:rPr>
+              <a:t>du liban moraleja</a:t>
+            </a:r>
+            <a:endParaRPr lang="en-US" sz="850" dirty="0"/>
+          </a:p>
+        </p:txBody>
+      </p:sp>
+      <p:sp>
+        <p:nvSpPr>
+          <p:cNvPr id="18" name="Shape 16"/>
+          <p:cNvSpPr/>
+          <p:nvPr/>
+        </p:nvSpPr>
+        <p:spPr>
+          <a:xfrm>
+            <a:off x="2148840" y="3337560"/>
+            <a:ext cx="578702" cy="114300"/>
+          </a:xfrm>
+          <a:prstGeom prst="rect">
+            <a:avLst/>
+          </a:prstGeom>
+          <a:solidFill>
+            <a:srgbClr val="00A6CE"/>
+          </a:solidFill>
+          <a:ln w="12700">
+            <a:solidFill>
+              <a:srgbClr val="00A6CE"/>
+            </a:solidFill>
+            <a:prstDash val="solid"/>
+          </a:ln>
+        </p:spPr>
+      </p:sp>
+      <p:sp>
+        <p:nvSpPr>
+          <p:cNvPr id="19" name="Text 17"/>
+          <p:cNvSpPr txBox="1"/>
+          <p:nvPr/>
+        </p:nvSpPr>
+        <p:spPr>
+          <a:xfrm>
+            <a:off x="2782406" y="3310128"/>
+            <a:ext cx="457200" cy="169164"/>
+          </a:xfrm>
+          <a:prstGeom prst="rect">
+            <a:avLst/>
+          </a:prstGeom>
+          <a:noFill/>
+          <a:ln/>
+        </p:spPr>
+        <p:txBody>
+          <a:bodyPr wrap="square" lIns="0" tIns="0" rIns="0" bIns="0" rtlCol="0" anchor="ctr"/>
+          <a:lstStyle/>
+          <a:p>
+            <a:pPr indent="0" marL="0">
+              <a:buNone/>
+            </a:pPr>
+            <a:r>
+              <a:rPr lang="en-US" sz="850" dirty="0">
+                <a:solidFill>
+                  <a:srgbClr val="3C3D3F"/>
+                </a:solidFill>
+                <a:latin typeface="Calibri" pitchFamily="34" charset="0"/>
+                <a:ea typeface="Calibri" pitchFamily="34" charset="-122"/>
+                <a:cs typeface="Calibri" pitchFamily="34" charset="-120"/>
+              </a:rPr>
+              <a:t>14</a:t>
+            </a:r>
+            <a:endParaRPr lang="en-US" sz="850" dirty="0"/>
+          </a:p>
+        </p:txBody>
+      </p:sp>
+      <p:sp>
+        <p:nvSpPr>
+          <p:cNvPr id="20" name="Text 18"/>
+          <p:cNvSpPr txBox="1"/>
+          <p:nvPr/>
+        </p:nvSpPr>
+        <p:spPr>
+          <a:xfrm>
+            <a:off x="457200" y="3479292"/>
+            <a:ext cx="1645920" cy="169164"/>
+          </a:xfrm>
+          <a:prstGeom prst="rect">
+            <a:avLst/>
+          </a:prstGeom>
+          <a:noFill/>
+          <a:ln/>
+        </p:spPr>
+        <p:txBody>
+          <a:bodyPr wrap="square" lIns="0" tIns="0" rIns="0" bIns="0" rtlCol="0" anchor="ctr"/>
+          <a:lstStyle/>
+          <a:p>
+            <a:pPr algn="r" indent="0" marL="0">
+              <a:buNone/>
+            </a:pPr>
+            <a:r>
+              <a:rPr lang="en-US" sz="850" dirty="0">
+                <a:solidFill>
+                  <a:srgbClr val="3C3D3F"/>
+                </a:solidFill>
+                <a:latin typeface="Calibri" pitchFamily="34" charset="0"/>
+                <a:ea typeface="Calibri" pitchFamily="34" charset="-122"/>
+                <a:cs typeface="Calibri" pitchFamily="34" charset="-120"/>
+              </a:rPr>
+              <a:t>du liban madrid</a:t>
+            </a:r>
+            <a:endParaRPr lang="en-US" sz="850" dirty="0"/>
+          </a:p>
+        </p:txBody>
+      </p:sp>
+      <p:sp>
+        <p:nvSpPr>
+          <p:cNvPr id="21" name="Shape 19"/>
+          <p:cNvSpPr/>
+          <p:nvPr/>
+        </p:nvSpPr>
+        <p:spPr>
+          <a:xfrm>
+            <a:off x="2148840" y="3506724"/>
+            <a:ext cx="454695" cy="114300"/>
+          </a:xfrm>
+          <a:prstGeom prst="rect">
+            <a:avLst/>
+          </a:prstGeom>
+          <a:solidFill>
+            <a:srgbClr val="00A6CE"/>
+          </a:solidFill>
+          <a:ln w="12700">
+            <a:solidFill>
+              <a:srgbClr val="00A6CE"/>
+            </a:solidFill>
+            <a:prstDash val="solid"/>
+          </a:ln>
+        </p:spPr>
+      </p:sp>
+      <p:sp>
+        <p:nvSpPr>
+          <p:cNvPr id="22" name="Text 20"/>
+          <p:cNvSpPr txBox="1"/>
+          <p:nvPr/>
+        </p:nvSpPr>
+        <p:spPr>
+          <a:xfrm>
+            <a:off x="2658399" y="3479292"/>
+            <a:ext cx="457200" cy="169164"/>
+          </a:xfrm>
+          <a:prstGeom prst="rect">
+            <a:avLst/>
+          </a:prstGeom>
+          <a:noFill/>
+          <a:ln/>
+        </p:spPr>
+        <p:txBody>
+          <a:bodyPr wrap="square" lIns="0" tIns="0" rIns="0" bIns="0" rtlCol="0" anchor="ctr"/>
+          <a:lstStyle/>
+          <a:p>
+            <a:pPr indent="0" marL="0">
+              <a:buNone/>
+            </a:pPr>
+            <a:r>
+              <a:rPr lang="en-US" sz="850" dirty="0">
+                <a:solidFill>
+                  <a:srgbClr val="3C3D3F"/>
+                </a:solidFill>
+                <a:latin typeface="Calibri" pitchFamily="34" charset="0"/>
+                <a:ea typeface="Calibri" pitchFamily="34" charset="-122"/>
+                <a:cs typeface="Calibri" pitchFamily="34" charset="-120"/>
+              </a:rPr>
+              <a:t>11</a:t>
+            </a:r>
+            <a:endParaRPr lang="en-US" sz="850" dirty="0"/>
+          </a:p>
+        </p:txBody>
+      </p:sp>
+      <p:sp>
+        <p:nvSpPr>
+          <p:cNvPr id="23" name="Text 21"/>
+          <p:cNvSpPr txBox="1"/>
+          <p:nvPr/>
+        </p:nvSpPr>
+        <p:spPr>
+          <a:xfrm>
+            <a:off x="457200" y="3648456"/>
+            <a:ext cx="1645920" cy="169164"/>
+          </a:xfrm>
+          <a:prstGeom prst="rect">
+            <a:avLst/>
+          </a:prstGeom>
+          <a:noFill/>
+          <a:ln/>
+        </p:spPr>
+        <p:txBody>
+          <a:bodyPr wrap="square" lIns="0" tIns="0" rIns="0" bIns="0" rtlCol="0" anchor="ctr"/>
+          <a:lstStyle/>
+          <a:p>
+            <a:pPr algn="r" indent="0" marL="0">
+              <a:buNone/>
+            </a:pPr>
+            <a:r>
+              <a:rPr lang="en-US" sz="850" dirty="0">
+                <a:solidFill>
+                  <a:srgbClr val="3C3D3F"/>
+                </a:solidFill>
+                <a:latin typeface="Calibri" pitchFamily="34" charset="0"/>
+                <a:ea typeface="Calibri" pitchFamily="34" charset="-122"/>
+                <a:cs typeface="Calibri" pitchFamily="34" charset="-120"/>
+              </a:rPr>
+              <a:t>duliban restaurante</a:t>
+            </a:r>
+            <a:endParaRPr lang="en-US" sz="850" dirty="0"/>
+          </a:p>
+        </p:txBody>
+      </p:sp>
+      <p:sp>
+        <p:nvSpPr>
+          <p:cNvPr id="24" name="Shape 22"/>
+          <p:cNvSpPr/>
+          <p:nvPr/>
+        </p:nvSpPr>
+        <p:spPr>
+          <a:xfrm>
+            <a:off x="2148840" y="3675888"/>
+            <a:ext cx="372023" cy="114300"/>
+          </a:xfrm>
+          <a:prstGeom prst="rect">
+            <a:avLst/>
+          </a:prstGeom>
+          <a:solidFill>
+            <a:srgbClr val="00A6CE"/>
+          </a:solidFill>
+          <a:ln w="12700">
+            <a:solidFill>
+              <a:srgbClr val="00A6CE"/>
+            </a:solidFill>
+            <a:prstDash val="solid"/>
+          </a:ln>
+        </p:spPr>
+      </p:sp>
+      <p:sp>
+        <p:nvSpPr>
+          <p:cNvPr id="25" name="Text 23"/>
+          <p:cNvSpPr txBox="1"/>
+          <p:nvPr/>
+        </p:nvSpPr>
+        <p:spPr>
+          <a:xfrm>
+            <a:off x="2575727" y="3648456"/>
+            <a:ext cx="457200" cy="169164"/>
+          </a:xfrm>
+          <a:prstGeom prst="rect">
+            <a:avLst/>
+          </a:prstGeom>
+          <a:noFill/>
+          <a:ln/>
+        </p:spPr>
+        <p:txBody>
+          <a:bodyPr wrap="square" lIns="0" tIns="0" rIns="0" bIns="0" rtlCol="0" anchor="ctr"/>
+          <a:lstStyle/>
+          <a:p>
+            <a:pPr indent="0" marL="0">
+              <a:buNone/>
+            </a:pPr>
+            <a:r>
+              <a:rPr lang="en-US" sz="850" dirty="0">
+                <a:solidFill>
+                  <a:srgbClr val="3C3D3F"/>
+                </a:solidFill>
+                <a:latin typeface="Calibri" pitchFamily="34" charset="0"/>
+                <a:ea typeface="Calibri" pitchFamily="34" charset="-122"/>
+                <a:cs typeface="Calibri" pitchFamily="34" charset="-120"/>
+              </a:rPr>
+              <a:t>9</a:t>
+            </a:r>
+            <a:endParaRPr lang="en-US" sz="850" dirty="0"/>
+          </a:p>
+        </p:txBody>
+      </p:sp>
+      <p:sp>
+        <p:nvSpPr>
+          <p:cNvPr id="26" name="Text 24"/>
+          <p:cNvSpPr txBox="1"/>
+          <p:nvPr/>
+        </p:nvSpPr>
+        <p:spPr>
+          <a:xfrm>
+            <a:off x="457200" y="3817620"/>
+            <a:ext cx="1645920" cy="169164"/>
+          </a:xfrm>
+          <a:prstGeom prst="rect">
+            <a:avLst/>
+          </a:prstGeom>
+          <a:noFill/>
+          <a:ln/>
+        </p:spPr>
+        <p:txBody>
+          <a:bodyPr wrap="square" lIns="0" tIns="0" rIns="0" bIns="0" rtlCol="0" anchor="ctr"/>
+          <a:lstStyle/>
+          <a:p>
+            <a:pPr algn="r" indent="0" marL="0">
+              <a:buNone/>
+            </a:pPr>
+            <a:r>
+              <a:rPr lang="en-US" sz="850" dirty="0">
+                <a:solidFill>
+                  <a:srgbClr val="3C3D3F"/>
+                </a:solidFill>
+                <a:latin typeface="Calibri" pitchFamily="34" charset="0"/>
+                <a:ea typeface="Calibri" pitchFamily="34" charset="-122"/>
+                <a:cs typeface="Calibri" pitchFamily="34" charset="-120"/>
+              </a:rPr>
+              <a:t>du liban restaurante</a:t>
+            </a:r>
+            <a:endParaRPr lang="en-US" sz="850" dirty="0"/>
+          </a:p>
+        </p:txBody>
+      </p:sp>
+      <p:sp>
+        <p:nvSpPr>
+          <p:cNvPr id="27" name="Shape 25"/>
+          <p:cNvSpPr/>
+          <p:nvPr/>
+        </p:nvSpPr>
+        <p:spPr>
+          <a:xfrm>
+            <a:off x="2148840" y="3845052"/>
+            <a:ext cx="372023" cy="114300"/>
+          </a:xfrm>
+          <a:prstGeom prst="rect">
+            <a:avLst/>
+          </a:prstGeom>
+          <a:solidFill>
+            <a:srgbClr val="00A6CE"/>
+          </a:solidFill>
+          <a:ln w="12700">
+            <a:solidFill>
+              <a:srgbClr val="00A6CE"/>
+            </a:solidFill>
+            <a:prstDash val="solid"/>
+          </a:ln>
+        </p:spPr>
+      </p:sp>
+      <p:sp>
+        <p:nvSpPr>
+          <p:cNvPr id="28" name="Text 26"/>
+          <p:cNvSpPr txBox="1"/>
+          <p:nvPr/>
+        </p:nvSpPr>
+        <p:spPr>
+          <a:xfrm>
+            <a:off x="2575727" y="3817620"/>
+            <a:ext cx="457200" cy="169164"/>
+          </a:xfrm>
+          <a:prstGeom prst="rect">
+            <a:avLst/>
+          </a:prstGeom>
+          <a:noFill/>
+          <a:ln/>
+        </p:spPr>
+        <p:txBody>
+          <a:bodyPr wrap="square" lIns="0" tIns="0" rIns="0" bIns="0" rtlCol="0" anchor="ctr"/>
+          <a:lstStyle/>
+          <a:p>
+            <a:pPr indent="0" marL="0">
+              <a:buNone/>
+            </a:pPr>
+            <a:r>
+              <a:rPr lang="en-US" sz="850" dirty="0">
+                <a:solidFill>
+                  <a:srgbClr val="3C3D3F"/>
+                </a:solidFill>
+                <a:latin typeface="Calibri" pitchFamily="34" charset="0"/>
+                <a:ea typeface="Calibri" pitchFamily="34" charset="-122"/>
+                <a:cs typeface="Calibri" pitchFamily="34" charset="-120"/>
+              </a:rPr>
+              <a:t>9</a:t>
+            </a:r>
+            <a:endParaRPr lang="en-US" sz="850" dirty="0"/>
+          </a:p>
+        </p:txBody>
+      </p:sp>
+      <p:sp>
+        <p:nvSpPr>
+          <p:cNvPr id="29" name="Text 27"/>
+          <p:cNvSpPr txBox="1"/>
+          <p:nvPr/>
+        </p:nvSpPr>
+        <p:spPr>
+          <a:xfrm>
+            <a:off x="457200" y="3986784"/>
+            <a:ext cx="1645920" cy="169164"/>
+          </a:xfrm>
+          <a:prstGeom prst="rect">
+            <a:avLst/>
+          </a:prstGeom>
+          <a:noFill/>
+          <a:ln/>
+        </p:spPr>
+        <p:txBody>
+          <a:bodyPr wrap="square" lIns="0" tIns="0" rIns="0" bIns="0" rtlCol="0" anchor="ctr"/>
+          <a:lstStyle/>
+          <a:p>
+            <a:pPr algn="r" indent="0" marL="0">
+              <a:buNone/>
+            </a:pPr>
+            <a:r>
+              <a:rPr lang="en-US" sz="850" dirty="0">
+                <a:solidFill>
+                  <a:srgbClr val="3C3D3F"/>
+                </a:solidFill>
+                <a:latin typeface="Calibri" pitchFamily="34" charset="0"/>
+                <a:ea typeface="Calibri" pitchFamily="34" charset="-122"/>
+                <a:cs typeface="Calibri" pitchFamily="34" charset="-120"/>
+              </a:rPr>
+              <a:t>duliban la moraleja</a:t>
+            </a:r>
+            <a:endParaRPr lang="en-US" sz="850" dirty="0"/>
+          </a:p>
+        </p:txBody>
+      </p:sp>
+      <p:sp>
+        <p:nvSpPr>
+          <p:cNvPr id="30" name="Shape 28"/>
+          <p:cNvSpPr/>
+          <p:nvPr/>
+        </p:nvSpPr>
+        <p:spPr>
+          <a:xfrm>
+            <a:off x="2148840" y="4014216"/>
+            <a:ext cx="330687" cy="114300"/>
+          </a:xfrm>
+          <a:prstGeom prst="rect">
+            <a:avLst/>
+          </a:prstGeom>
+          <a:solidFill>
+            <a:srgbClr val="00A6CE"/>
+          </a:solidFill>
+          <a:ln w="12700">
+            <a:solidFill>
+              <a:srgbClr val="00A6CE"/>
+            </a:solidFill>
+            <a:prstDash val="solid"/>
+          </a:ln>
+        </p:spPr>
+      </p:sp>
+      <p:sp>
+        <p:nvSpPr>
+          <p:cNvPr id="31" name="Text 29"/>
+          <p:cNvSpPr txBox="1"/>
+          <p:nvPr/>
+        </p:nvSpPr>
+        <p:spPr>
+          <a:xfrm>
+            <a:off x="2534391" y="3986784"/>
+            <a:ext cx="457200" cy="169164"/>
+          </a:xfrm>
+          <a:prstGeom prst="rect">
+            <a:avLst/>
+          </a:prstGeom>
+          <a:noFill/>
+          <a:ln/>
+        </p:spPr>
+        <p:txBody>
+          <a:bodyPr wrap="square" lIns="0" tIns="0" rIns="0" bIns="0" rtlCol="0" anchor="ctr"/>
+          <a:lstStyle/>
+          <a:p>
+            <a:pPr indent="0" marL="0">
+              <a:buNone/>
+            </a:pPr>
+            <a:r>
+              <a:rPr lang="en-US" sz="850" dirty="0">
+                <a:solidFill>
+                  <a:srgbClr val="3C3D3F"/>
+                </a:solidFill>
+                <a:latin typeface="Calibri" pitchFamily="34" charset="0"/>
+                <a:ea typeface="Calibri" pitchFamily="34" charset="-122"/>
+                <a:cs typeface="Calibri" pitchFamily="34" charset="-120"/>
+              </a:rPr>
+              <a:t>8</a:t>
+            </a:r>
+            <a:endParaRPr lang="en-US" sz="850" dirty="0"/>
+          </a:p>
+        </p:txBody>
+      </p:sp>
+      <p:sp>
+        <p:nvSpPr>
+          <p:cNvPr id="32" name="Text 30"/>
+          <p:cNvSpPr txBox="1"/>
+          <p:nvPr/>
+        </p:nvSpPr>
+        <p:spPr>
+          <a:xfrm>
+            <a:off x="457200" y="4155948"/>
+            <a:ext cx="1645920" cy="169164"/>
+          </a:xfrm>
+          <a:prstGeom prst="rect">
+            <a:avLst/>
+          </a:prstGeom>
+          <a:noFill/>
+          <a:ln/>
+        </p:spPr>
+        <p:txBody>
+          <a:bodyPr wrap="square" lIns="0" tIns="0" rIns="0" bIns="0" rtlCol="0" anchor="ctr"/>
+          <a:lstStyle/>
+          <a:p>
+            <a:pPr algn="r" indent="0" marL="0">
+              <a:buNone/>
+            </a:pPr>
+            <a:r>
+              <a:rPr lang="en-US" sz="850" dirty="0">
+                <a:solidFill>
+                  <a:srgbClr val="3C3D3F"/>
+                </a:solidFill>
+                <a:latin typeface="Calibri" pitchFamily="34" charset="0"/>
+                <a:ea typeface="Calibri" pitchFamily="34" charset="-122"/>
+                <a:cs typeface="Calibri" pitchFamily="34" charset="-120"/>
+              </a:rPr>
+              <a:t>restaurante du liban</a:t>
+            </a:r>
+            <a:endParaRPr lang="en-US" sz="850" dirty="0"/>
+          </a:p>
+        </p:txBody>
+      </p:sp>
+      <p:sp>
+        <p:nvSpPr>
+          <p:cNvPr id="33" name="Shape 31"/>
+          <p:cNvSpPr/>
+          <p:nvPr/>
+        </p:nvSpPr>
+        <p:spPr>
+          <a:xfrm>
+            <a:off x="2148840" y="4183380"/>
+            <a:ext cx="289351" cy="114300"/>
+          </a:xfrm>
+          <a:prstGeom prst="rect">
+            <a:avLst/>
+          </a:prstGeom>
+          <a:solidFill>
+            <a:srgbClr val="00A6CE"/>
+          </a:solidFill>
+          <a:ln w="12700">
+            <a:solidFill>
+              <a:srgbClr val="00A6CE"/>
+            </a:solidFill>
+            <a:prstDash val="solid"/>
+          </a:ln>
+        </p:spPr>
+      </p:sp>
+      <p:sp>
+        <p:nvSpPr>
+          <p:cNvPr id="34" name="Text 32"/>
+          <p:cNvSpPr txBox="1"/>
+          <p:nvPr/>
+        </p:nvSpPr>
+        <p:spPr>
+          <a:xfrm>
+            <a:off x="2493055" y="4155948"/>
+            <a:ext cx="457200" cy="169164"/>
+          </a:xfrm>
+          <a:prstGeom prst="rect">
+            <a:avLst/>
+          </a:prstGeom>
+          <a:noFill/>
+          <a:ln/>
+        </p:spPr>
+        <p:txBody>
+          <a:bodyPr wrap="square" lIns="0" tIns="0" rIns="0" bIns="0" rtlCol="0" anchor="ctr"/>
+          <a:lstStyle/>
+          <a:p>
+            <a:pPr indent="0" marL="0">
+              <a:buNone/>
+            </a:pPr>
+            <a:r>
+              <a:rPr lang="en-US" sz="850" dirty="0">
+                <a:solidFill>
+                  <a:srgbClr val="3C3D3F"/>
+                </a:solidFill>
+                <a:latin typeface="Calibri" pitchFamily="34" charset="0"/>
+                <a:ea typeface="Calibri" pitchFamily="34" charset="-122"/>
+                <a:cs typeface="Calibri" pitchFamily="34" charset="-120"/>
+              </a:rPr>
+              <a:t>7</a:t>
+            </a:r>
+            <a:endParaRPr lang="en-US" sz="850" dirty="0"/>
+          </a:p>
+        </p:txBody>
+      </p:sp>
+      <p:sp>
+        <p:nvSpPr>
+          <p:cNvPr id="35" name="Text 33"/>
+          <p:cNvSpPr txBox="1"/>
+          <p:nvPr/>
+        </p:nvSpPr>
+        <p:spPr>
+          <a:xfrm>
+            <a:off x="457200" y="4325112"/>
+            <a:ext cx="1645920" cy="169164"/>
+          </a:xfrm>
+          <a:prstGeom prst="rect">
+            <a:avLst/>
+          </a:prstGeom>
+          <a:noFill/>
+          <a:ln/>
+        </p:spPr>
+        <p:txBody>
+          <a:bodyPr wrap="square" lIns="0" tIns="0" rIns="0" bIns="0" rtlCol="0" anchor="ctr"/>
+          <a:lstStyle/>
+          <a:p>
+            <a:pPr algn="r" indent="0" marL="0">
+              <a:buNone/>
+            </a:pPr>
+            <a:r>
+              <a:rPr lang="en-US" sz="850" dirty="0">
+                <a:solidFill>
+                  <a:srgbClr val="3C3D3F"/>
+                </a:solidFill>
+                <a:latin typeface="Calibri" pitchFamily="34" charset="0"/>
+                <a:ea typeface="Calibri" pitchFamily="34" charset="-122"/>
+                <a:cs typeface="Calibri" pitchFamily="34" charset="-120"/>
+              </a:rPr>
+              <a:t>du liban la moraleja</a:t>
+            </a:r>
+            <a:endParaRPr lang="en-US" sz="850" dirty="0"/>
+          </a:p>
+        </p:txBody>
+      </p:sp>
+      <p:sp>
+        <p:nvSpPr>
+          <p:cNvPr id="36" name="Shape 34"/>
+          <p:cNvSpPr/>
+          <p:nvPr/>
+        </p:nvSpPr>
+        <p:spPr>
+          <a:xfrm>
+            <a:off x="2148840" y="4352544"/>
+            <a:ext cx="206679" cy="114300"/>
+          </a:xfrm>
+          <a:prstGeom prst="rect">
+            <a:avLst/>
+          </a:prstGeom>
+          <a:solidFill>
+            <a:srgbClr val="00A6CE"/>
+          </a:solidFill>
+          <a:ln w="12700">
+            <a:solidFill>
+              <a:srgbClr val="00A6CE"/>
+            </a:solidFill>
+            <a:prstDash val="solid"/>
+          </a:ln>
+        </p:spPr>
+      </p:sp>
+      <p:sp>
+        <p:nvSpPr>
+          <p:cNvPr id="37" name="Text 35"/>
+          <p:cNvSpPr txBox="1"/>
+          <p:nvPr/>
+        </p:nvSpPr>
+        <p:spPr>
+          <a:xfrm>
+            <a:off x="2410383" y="4325112"/>
+            <a:ext cx="457200" cy="169164"/>
+          </a:xfrm>
+          <a:prstGeom prst="rect">
+            <a:avLst/>
+          </a:prstGeom>
+          <a:noFill/>
+          <a:ln/>
+        </p:spPr>
+        <p:txBody>
+          <a:bodyPr wrap="square" lIns="0" tIns="0" rIns="0" bIns="0" rtlCol="0" anchor="ctr"/>
+          <a:lstStyle/>
+          <a:p>
+            <a:pPr indent="0" marL="0">
+              <a:buNone/>
+            </a:pPr>
+            <a:r>
+              <a:rPr lang="en-US" sz="850" dirty="0">
+                <a:solidFill>
+                  <a:srgbClr val="3C3D3F"/>
+                </a:solidFill>
+                <a:latin typeface="Calibri" pitchFamily="34" charset="0"/>
+                <a:ea typeface="Calibri" pitchFamily="34" charset="-122"/>
+                <a:cs typeface="Calibri" pitchFamily="34" charset="-120"/>
+              </a:rPr>
+              <a:t>5</a:t>
+            </a:r>
+            <a:endParaRPr lang="en-US" sz="850" dirty="0"/>
+          </a:p>
+        </p:txBody>
+      </p:sp>
+      <p:sp>
+        <p:nvSpPr>
+          <p:cNvPr id="38" name="Text 36"/>
+          <p:cNvSpPr txBox="1"/>
+          <p:nvPr/>
+        </p:nvSpPr>
+        <p:spPr>
+          <a:xfrm>
+            <a:off x="457200" y="4494276"/>
+            <a:ext cx="1645920" cy="169164"/>
+          </a:xfrm>
+          <a:prstGeom prst="rect">
+            <a:avLst/>
+          </a:prstGeom>
+          <a:noFill/>
+          <a:ln/>
+        </p:spPr>
+        <p:txBody>
+          <a:bodyPr wrap="square" lIns="0" tIns="0" rIns="0" bIns="0" rtlCol="0" anchor="ctr"/>
+          <a:lstStyle/>
+          <a:p>
+            <a:pPr algn="r" indent="0" marL="0">
+              <a:buNone/>
+            </a:pPr>
+            <a:r>
+              <a:rPr lang="en-US" sz="850" dirty="0">
+                <a:solidFill>
+                  <a:srgbClr val="3C3D3F"/>
+                </a:solidFill>
+                <a:latin typeface="Calibri" pitchFamily="34" charset="0"/>
+                <a:ea typeface="Calibri" pitchFamily="34" charset="-122"/>
+                <a:cs typeface="Calibri" pitchFamily="34" charset="-120"/>
+              </a:rPr>
+              <a:t>libanes la moraleja</a:t>
+            </a:r>
+            <a:endParaRPr lang="en-US" sz="850" dirty="0"/>
+          </a:p>
+        </p:txBody>
+      </p:sp>
+      <p:sp>
+        <p:nvSpPr>
+          <p:cNvPr id="39" name="Shape 37"/>
+          <p:cNvSpPr/>
+          <p:nvPr/>
+        </p:nvSpPr>
+        <p:spPr>
+          <a:xfrm>
+            <a:off x="2148840" y="4521708"/>
+            <a:ext cx="206679" cy="114300"/>
+          </a:xfrm>
+          <a:prstGeom prst="rect">
+            <a:avLst/>
+          </a:prstGeom>
+          <a:solidFill>
+            <a:srgbClr val="0A7390"/>
+          </a:solidFill>
+          <a:ln w="12700">
+            <a:solidFill>
+              <a:srgbClr val="0A7390"/>
+            </a:solidFill>
+            <a:prstDash val="solid"/>
+          </a:ln>
+        </p:spPr>
+      </p:sp>
+      <p:sp>
+        <p:nvSpPr>
+          <p:cNvPr id="40" name="Text 38"/>
+          <p:cNvSpPr txBox="1"/>
+          <p:nvPr/>
+        </p:nvSpPr>
+        <p:spPr>
+          <a:xfrm>
+            <a:off x="2410383" y="4494276"/>
+            <a:ext cx="457200" cy="169164"/>
+          </a:xfrm>
+          <a:prstGeom prst="rect">
+            <a:avLst/>
+          </a:prstGeom>
+          <a:noFill/>
+          <a:ln/>
+        </p:spPr>
+        <p:txBody>
+          <a:bodyPr wrap="square" lIns="0" tIns="0" rIns="0" bIns="0" rtlCol="0" anchor="ctr"/>
+          <a:lstStyle/>
+          <a:p>
+            <a:pPr indent="0" marL="0">
+              <a:buNone/>
+            </a:pPr>
+            <a:r>
+              <a:rPr lang="en-US" sz="850" dirty="0">
+                <a:solidFill>
+                  <a:srgbClr val="3C3D3F"/>
+                </a:solidFill>
+                <a:latin typeface="Calibri" pitchFamily="34" charset="0"/>
+                <a:ea typeface="Calibri" pitchFamily="34" charset="-122"/>
+                <a:cs typeface="Calibri" pitchFamily="34" charset="-120"/>
+              </a:rPr>
+              <a:t>5</a:t>
+            </a:r>
+            <a:endParaRPr lang="en-US" sz="850" dirty="0"/>
+          </a:p>
+        </p:txBody>
+      </p:sp>
+      <p:sp>
+        <p:nvSpPr>
+          <p:cNvPr id="41" name="Shape 39"/>
           <p:cNvSpPr/>
           <p:nvPr/>
         </p:nvSpPr>
@@ -4395,7 +5038,7 @@
       </p:sp>
       <p:sp>
         <p:nvSpPr>
-          <p:cNvPr id="12" name="Text 9"/>
+          <p:cNvPr id="42" name="Text 40"/>
           <p:cNvSpPr txBox="1"/>
           <p:nvPr/>
         </p:nvSpPr>
@@ -4434,7 +5077,7 @@
       </p:sp>
       <p:sp>
         <p:nvSpPr>
-          <p:cNvPr id="13" name="Text 10"/>
+          <p:cNvPr id="43" name="Text 41"/>
           <p:cNvSpPr txBox="1"/>
           <p:nvPr/>
         </p:nvSpPr>
@@ -4473,7 +5116,7 @@
       </p:sp>
       <p:sp>
         <p:nvSpPr>
-          <p:cNvPr id="14" name="Text 11"/>
+          <p:cNvPr id="44" name="Text 42"/>
           <p:cNvSpPr txBox="1"/>
           <p:nvPr/>
         </p:nvSpPr>
@@ -6101,6 +6744,17 @@
                       <a:pPr indent="0" marL="0">
                         <a:buNone/>
                       </a:pPr>
+                      <a:r>
+                        <a:rPr lang="en-US" sz="1200" dirty="0">
+                          <a:solidFill>
+                            <a:srgbClr val="000000"/>
+                          </a:solidFill>
+                          <a:latin typeface="Calibri" pitchFamily="34" charset="0"/>
+                          <a:ea typeface="Calibri" pitchFamily="34" charset="-122"/>
+                          <a:cs typeface="Calibri" pitchFamily="34" charset="-120"/>
+                        </a:rPr>
+                        <a:t> </a:t>
+                      </a:r>
                       <a:endParaRPr lang="en-US" sz="1200" dirty="0">
                         <a:latin typeface="Calibri" charset="0"/>
                         <a:ea typeface="Calibri" charset="0"/>

</xml_diff>